<commit_message>
new viz in ppt
</commit_message>
<xml_diff>
--- a/ad24-1-presentation.pptx
+++ b/ad24-1-presentation.pptx
@@ -2336,7 +2336,7 @@
           <a:p>
             <a:fld id="{C764DE79-268F-4C1A-8933-263129D2AF90}" type="datetimeFigureOut">
               <a:rPr lang="en-US" smtClean="0"/>
-              <a:t>5/29/2026</a:t>
+              <a:t>5/31/2026</a:t>
             </a:fld>
             <a:endParaRPr lang="en-US" dirty="0"/>
           </a:p>
@@ -2507,7 +2507,7 @@
           <a:p>
             <a:fld id="{C764DE79-268F-4C1A-8933-263129D2AF90}" type="datetimeFigureOut">
               <a:rPr lang="en-US" smtClean="0"/>
-              <a:t>5/29/2026</a:t>
+              <a:t>5/31/2026</a:t>
             </a:fld>
             <a:endParaRPr lang="en-US" dirty="0"/>
           </a:p>
@@ -2688,7 +2688,7 @@
           <a:p>
             <a:fld id="{C764DE79-268F-4C1A-8933-263129D2AF90}" type="datetimeFigureOut">
               <a:rPr lang="en-US" smtClean="0"/>
-              <a:t>5/29/2026</a:t>
+              <a:t>5/31/2026</a:t>
             </a:fld>
             <a:endParaRPr lang="en-US" dirty="0"/>
           </a:p>
@@ -2889,7 +2889,7 @@
           <a:p>
             <a:fld id="{C764DE79-268F-4C1A-8933-263129D2AF90}" type="datetimeFigureOut">
               <a:rPr lang="en-US" smtClean="0"/>
-              <a:t>5/29/2026</a:t>
+              <a:t>5/31/2026</a:t>
             </a:fld>
             <a:endParaRPr lang="en-US" dirty="0"/>
           </a:p>
@@ -3136,7 +3136,7 @@
           <a:p>
             <a:fld id="{C764DE79-268F-4C1A-8933-263129D2AF90}" type="datetimeFigureOut">
               <a:rPr lang="en-US" smtClean="0"/>
-              <a:t>5/29/2026</a:t>
+              <a:t>5/31/2026</a:t>
             </a:fld>
             <a:endParaRPr lang="en-US" dirty="0"/>
           </a:p>
@@ -3369,7 +3369,7 @@
           <a:p>
             <a:fld id="{C764DE79-268F-4C1A-8933-263129D2AF90}" type="datetimeFigureOut">
               <a:rPr lang="en-US" smtClean="0"/>
-              <a:t>5/29/2026</a:t>
+              <a:t>5/31/2026</a:t>
             </a:fld>
             <a:endParaRPr lang="en-US" dirty="0"/>
           </a:p>
@@ -3737,7 +3737,7 @@
           <a:p>
             <a:fld id="{C764DE79-268F-4C1A-8933-263129D2AF90}" type="datetimeFigureOut">
               <a:rPr lang="en-US" smtClean="0"/>
-              <a:t>5/29/2026</a:t>
+              <a:t>5/31/2026</a:t>
             </a:fld>
             <a:endParaRPr lang="en-US" dirty="0"/>
           </a:p>
@@ -3856,7 +3856,7 @@
           <a:p>
             <a:fld id="{C764DE79-268F-4C1A-8933-263129D2AF90}" type="datetimeFigureOut">
               <a:rPr lang="en-US" smtClean="0"/>
-              <a:t>5/29/2026</a:t>
+              <a:t>5/31/2026</a:t>
             </a:fld>
             <a:endParaRPr lang="en-US" dirty="0"/>
           </a:p>
@@ -3952,7 +3952,7 @@
           <a:p>
             <a:fld id="{C764DE79-268F-4C1A-8933-263129D2AF90}" type="datetimeFigureOut">
               <a:rPr lang="en-US" smtClean="0"/>
-              <a:t>5/29/2026</a:t>
+              <a:t>5/31/2026</a:t>
             </a:fld>
             <a:endParaRPr lang="en-US" dirty="0"/>
           </a:p>
@@ -4230,7 +4230,7 @@
           <a:p>
             <a:fld id="{C764DE79-268F-4C1A-8933-263129D2AF90}" type="datetimeFigureOut">
               <a:rPr lang="en-US" smtClean="0"/>
-              <a:t>5/29/2026</a:t>
+              <a:t>5/31/2026</a:t>
             </a:fld>
             <a:endParaRPr lang="en-US" dirty="0"/>
           </a:p>
@@ -4488,7 +4488,7 @@
           <a:p>
             <a:fld id="{C764DE79-268F-4C1A-8933-263129D2AF90}" type="datetimeFigureOut">
               <a:rPr lang="en-US" smtClean="0"/>
-              <a:t>5/29/2026</a:t>
+              <a:t>5/31/2026</a:t>
             </a:fld>
             <a:endParaRPr lang="en-US" dirty="0"/>
           </a:p>
@@ -4705,7 +4705,7 @@
           <a:p>
             <a:fld id="{C764DE79-268F-4C1A-8933-263129D2AF90}" type="datetimeFigureOut">
               <a:rPr lang="en-US" smtClean="0"/>
-              <a:t>5/29/2026</a:t>
+              <a:t>5/31/2026</a:t>
             </a:fld>
             <a:endParaRPr lang="en-US" dirty="0"/>
           </a:p>
@@ -6221,10 +6221,10 @@
       </p:sp>
       <p:pic>
         <p:nvPicPr>
-          <p:cNvPr id="7" name="Grafik 6">
+          <p:cNvPr id="8" name="Grafik 7">
             <a:extLst>
               <a:ext uri="{FF2B5EF4-FFF2-40B4-BE49-F238E27FC236}">
-                <a16:creationId xmlns:a16="http://schemas.microsoft.com/office/drawing/2014/main" id="{0DF390EF-F58E-918A-8D94-4D3B97C816CE}"/>
+                <a16:creationId xmlns:a16="http://schemas.microsoft.com/office/drawing/2014/main" id="{474FCA6C-3A28-091E-A209-55A197EEBEB3}"/>
               </a:ext>
             </a:extLst>
           </p:cNvPr>
@@ -6241,8 +6241,8 @@
         </p:blipFill>
         <p:spPr>
           <a:xfrm>
-            <a:off x="411481" y="1432091"/>
-            <a:ext cx="4361992" cy="3271494"/>
+            <a:off x="569783" y="1298448"/>
+            <a:ext cx="3999241" cy="3373273"/>
           </a:xfrm>
           <a:prstGeom prst="rect">
             <a:avLst/>
@@ -12394,36 +12394,6 @@
           </a:p>
         </p:txBody>
       </p:sp>
-      <p:pic>
-        <p:nvPicPr>
-          <p:cNvPr id="32" name="Grafik 31">
-            <a:extLst>
-              <a:ext uri="{FF2B5EF4-FFF2-40B4-BE49-F238E27FC236}">
-                <a16:creationId xmlns:a16="http://schemas.microsoft.com/office/drawing/2014/main" id="{2FE98949-574C-F6CC-2985-D9AA1961F960}"/>
-              </a:ext>
-            </a:extLst>
-          </p:cNvPr>
-          <p:cNvPicPr>
-            <a:picLocks noChangeAspect="1"/>
-          </p:cNvPicPr>
-          <p:nvPr/>
-        </p:nvPicPr>
-        <p:blipFill>
-          <a:blip r:embed="rId3"/>
-          <a:stretch>
-            <a:fillRect/>
-          </a:stretch>
-        </p:blipFill>
-        <p:spPr>
-          <a:xfrm>
-            <a:off x="292133" y="1665669"/>
-            <a:ext cx="4470995" cy="2489008"/>
-          </a:xfrm>
-          <a:prstGeom prst="rect">
-            <a:avLst/>
-          </a:prstGeom>
-        </p:spPr>
-      </p:pic>
       <p:sp>
         <p:nvSpPr>
           <p:cNvPr id="33" name="Shape 5">
@@ -12626,6 +12596,36 @@
           </a:p>
         </p:txBody>
       </p:sp>
+      <p:pic>
+        <p:nvPicPr>
+          <p:cNvPr id="7" name="Grafik 6">
+            <a:extLst>
+              <a:ext uri="{FF2B5EF4-FFF2-40B4-BE49-F238E27FC236}">
+                <a16:creationId xmlns:a16="http://schemas.microsoft.com/office/drawing/2014/main" id="{599599DD-B8EC-8909-DCA2-9401C7DF5C0D}"/>
+              </a:ext>
+            </a:extLst>
+          </p:cNvPr>
+          <p:cNvPicPr>
+            <a:picLocks noChangeAspect="1"/>
+          </p:cNvPicPr>
+          <p:nvPr/>
+        </p:nvPicPr>
+        <p:blipFill>
+          <a:blip r:embed="rId3"/>
+          <a:stretch>
+            <a:fillRect/>
+          </a:stretch>
+        </p:blipFill>
+        <p:spPr>
+          <a:xfrm>
+            <a:off x="536835" y="1391986"/>
+            <a:ext cx="4231342" cy="3168396"/>
+          </a:xfrm>
+          <a:prstGeom prst="rect">
+            <a:avLst/>
+          </a:prstGeom>
+        </p:spPr>
+      </p:pic>
     </p:spTree>
     <p:extLst>
       <p:ext uri="{BB962C8B-B14F-4D97-AF65-F5344CB8AC3E}">
@@ -13492,10 +13492,10 @@
       </p:sp>
       <p:pic>
         <p:nvPicPr>
-          <p:cNvPr id="7" name="Grafik 6">
+          <p:cNvPr id="8" name="Grafik 7">
             <a:extLst>
               <a:ext uri="{FF2B5EF4-FFF2-40B4-BE49-F238E27FC236}">
-                <a16:creationId xmlns:a16="http://schemas.microsoft.com/office/drawing/2014/main" id="{9BBFF401-BE3E-C10E-5E35-EC394525F253}"/>
+                <a16:creationId xmlns:a16="http://schemas.microsoft.com/office/drawing/2014/main" id="{86114617-6CC9-8939-3FC9-674885690343}"/>
               </a:ext>
             </a:extLst>
           </p:cNvPr>
@@ -13512,8 +13512,8 @@
         </p:blipFill>
         <p:spPr>
           <a:xfrm>
-            <a:off x="603503" y="1298448"/>
-            <a:ext cx="3465575" cy="3465575"/>
+            <a:off x="728660" y="1298448"/>
+            <a:ext cx="3618470" cy="3534156"/>
           </a:xfrm>
           <a:prstGeom prst="rect">
             <a:avLst/>

</xml_diff>